<commit_message>
Refine copy to a professional business register across deck, PPTX and mobile/PDF
Co-Authored-By: Claude Opus 4.8 (1M context) <noreply@anthropic.com>
</commit_message>
<xml_diff>
--- a/TA-Strategy.pptx
+++ b/TA-Strategy.pptx
@@ -3361,7 +3361,7 @@
                 </a:solidFill>
                 <a:latin typeface="Calibri"/>
               </a:rPr>
-              <a:t>Building a strong </a:t>
+              <a:t>Building a scalable </a:t>
             </a:r>
             <a:r>
               <a:rPr sz="3800" b="1" i="0">
@@ -3437,7 +3437,7 @@
                 </a:solidFill>
                 <a:latin typeface="Calibri"/>
               </a:rPr>
-              <a:t>A simple, practical plan to hire faster, stop people from leaving, and make hiring a key driver of business growth.</a:t>
+              <a:t>A practical Talent Acquisition strategy to hire faster, reduce attrition, and make hiring a key driver of business growth.</a:t>
             </a:r>
           </a:p>
         </p:txBody>
@@ -3705,7 +3705,7 @@
                 </a:solidFill>
                 <a:latin typeface="Calibri"/>
               </a:rPr>
-              <a:t>REVENUE, NEXT 12–24 MONTHS</a:t>
+              <a:t>REVENUE TARGET, NEXT 12–24 MONTHS</a:t>
             </a:r>
           </a:p>
         </p:txBody>
@@ -3839,7 +3839,7 @@
                 </a:solidFill>
                 <a:latin typeface="Calibri"/>
               </a:rPr>
-              <a:t>PEOPLE TO HIRE EVERY YEAR</a:t>
+              <a:t>HIRES REQUIRED PER YEAR</a:t>
             </a:r>
           </a:p>
         </p:txBody>
@@ -3973,7 +3973,7 @@
                 </a:solidFill>
                 <a:latin typeface="Calibri"/>
               </a:rPr>
-              <a:t>REDUCE PEOPLE LEAVING</a:t>
+              <a:t>REDUCE ATTRITION</a:t>
             </a:r>
           </a:p>
         </p:txBody>
@@ -4107,7 +4107,7 @@
                 </a:solidFill>
                 <a:latin typeface="Calibri"/>
               </a:rPr>
-              <a:t>REDUCE HIRING TIME</a:t>
+              <a:t>REDUCE TIME-TO-HIRE</a:t>
             </a:r>
           </a:p>
         </p:txBody>
@@ -4648,7 +4648,7 @@
                 </a:solidFill>
                 <a:latin typeface="Calibri"/>
               </a:rPr>
-              <a:t>“We cannot reach ₹5,000 Cr if 45% of people keep leaving. Fix retention and speed together — faster, cheaper, and people who stay.”</a:t>
+              <a:t>“We cannot reach ₹5,000 Cr while 45% of our people keep leaving. By fixing retention and speed together, the same hiring delivers genuine growth — faster, more cost-effective, and built to last.”</a:t>
             </a:r>
           </a:p>
         </p:txBody>
@@ -4916,7 +4916,7 @@
                 </a:solidFill>
                 <a:latin typeface="Calibri"/>
               </a:rPr>
-              <a:t>AVERAGE HIRING TIME</a:t>
+              <a:t>AVERAGE TIME-TO-HIRE</a:t>
             </a:r>
           </a:p>
         </p:txBody>
@@ -5050,7 +5050,7 @@
                 </a:solidFill>
                 <a:latin typeface="Calibri"/>
               </a:rPr>
-              <a:t>PEOPLE LEAVING</a:t>
+              <a:t>ATTRITION</a:t>
             </a:r>
           </a:p>
         </p:txBody>
@@ -5184,7 +5184,7 @@
                 </a:solidFill>
                 <a:latin typeface="Calibri"/>
               </a:rPr>
-              <a:t>COST PER HIRE (HALF)</a:t>
+              <a:t>COST PER HIRE (HALVED)</a:t>
             </a:r>
           </a:p>
         </p:txBody>
@@ -5318,7 +5318,7 @@
                 </a:solidFill>
                 <a:latin typeface="Calibri"/>
               </a:rPr>
-              <a:t>GROWTH SUPPORTED</a:t>
+              <a:t>GROWTH ENABLED</a:t>
             </a:r>
           </a:p>
         </p:txBody>
@@ -5790,7 +5790,7 @@
                 </a:solidFill>
                 <a:latin typeface="Calibri"/>
               </a:rPr>
-              <a:t>From a slow hiring desk to a smart hiring system</a:t>
+              <a:t>Moving from reactive hiring to a proactive system</a:t>
             </a:r>
           </a:p>
         </p:txBody>
@@ -5835,7 +5835,7 @@
                 </a:solidFill>
                 <a:latin typeface="Calibri"/>
               </a:rPr>
-              <a:t>Today we hire only after a job opens. We will change this — plan hiring early from new-store plans and keep candidates ready in advance. We will hire good people who stay longer, not just fill seats fast.</a:t>
+              <a:t>Currently we hire only after a role opens. We will shift to planning hiring ahead of demand — based on the store-expansion roadmap — and keep pre-screened candidates ready. The focus moves to hiring quality talent that stays, not simply filling roles quickly.</a:t>
             </a:r>
           </a:p>
         </p:txBody>
@@ -6017,7 +6017,7 @@
                 </a:solidFill>
                 <a:latin typeface="Calibri"/>
               </a:rPr>
-              <a:t>Ready candidate lists + AI + clear timelines, run by TA Ops.</a:t>
+              <a:t>Talent pipelines + AI + clear timelines, managed by TA Ops.</a:t>
             </a:r>
           </a:p>
         </p:txBody>
@@ -6062,7 +6062,7 @@
                 </a:solidFill>
                 <a:latin typeface="Calibri"/>
               </a:rPr>
-              <a:t>Goal: hire in 30 days</a:t>
+              <a:t>Goal: hire within 30 days</a:t>
             </a:r>
           </a:p>
         </p:txBody>
@@ -6244,7 +6244,7 @@
                 </a:solidFill>
                 <a:latin typeface="Calibri"/>
               </a:rPr>
-              <a:t>Proper interview scorecards + an honest job preview.</a:t>
+              <a:t>Structured interviews + an honest role preview.</a:t>
             </a:r>
           </a:p>
         </p:txBody>
@@ -6289,7 +6289,7 @@
                 </a:solidFill>
                 <a:latin typeface="Calibri"/>
               </a:rPr>
-              <a:t>Goal: joinees stay past 90 days</a:t>
+              <a:t>Goal: new hires staying past 90 days</a:t>
             </a:r>
           </a:p>
         </p:txBody>
@@ -6426,7 +6426,7 @@
                 </a:solidFill>
                 <a:latin typeface="Calibri"/>
               </a:rPr>
-              <a:t>⚙️ Low cost</a:t>
+              <a:t>⚙️ Cost-efficiency</a:t>
             </a:r>
           </a:p>
         </p:txBody>
@@ -6653,7 +6653,7 @@
                 </a:solidFill>
                 <a:latin typeface="Calibri"/>
               </a:rPr>
-              <a:t>✨ Brand</a:t>
+              <a:t>✨ Employer brand</a:t>
             </a:r>
           </a:p>
         </p:txBody>
@@ -6698,7 +6698,7 @@
                 </a:solidFill>
                 <a:latin typeface="Calibri"/>
               </a:rPr>
-              <a:t>Regular social posts + the Apple brand value.</a:t>
+              <a:t>A consistent social presence + the Apple brand advantage.</a:t>
             </a:r>
           </a:p>
         </p:txBody>
@@ -6743,7 +6743,7 @@
                 </a:solidFill>
                 <a:latin typeface="Calibri"/>
               </a:rPr>
-              <a:t>Goal: more offers accepted</a:t>
+              <a:t>Goal: higher offer acceptance</a:t>
             </a:r>
           </a:p>
         </p:txBody>
@@ -6880,7 +6880,7 @@
                 </a:solidFill>
                 <a:latin typeface="Calibri"/>
               </a:rPr>
-              <a:t>Four focus areas, each with one owner and one clear number to track — so the plan stays simple and accountable.</a:t>
+              <a:t>Four focus areas, each with a clear owner and a single metric — keeping the plan simple and accountable.</a:t>
             </a:r>
           </a:p>
         </p:txBody>
@@ -7352,7 +7352,7 @@
                 </a:solidFill>
                 <a:latin typeface="Calibri"/>
               </a:rPr>
-              <a:t>First 90 days — a step-by-step plan</a:t>
+              <a:t>The first 90 days — a phased plan</a:t>
             </a:r>
           </a:p>
         </p:txBody>
@@ -7397,7 +7397,7 @@
                 </a:solidFill>
                 <a:latin typeface="Calibri"/>
               </a:rPr>
-              <a:t>Done in order — we cannot speed up a broken process. First fix the basics, then build the system, then show results. Quick early wins build trust for the bigger changes.</a:t>
+              <a:t>Sequenced deliberately — a broken process cannot be scaled. First fix the basics, then build the system, then demonstrate results. Early wins build confidence for the larger changes.</a:t>
             </a:r>
           </a:p>
         </p:txBody>
@@ -7581,7 +7581,7 @@
                 </a:solidFill>
                 <a:latin typeface="Calibri"/>
               </a:rPr>
-              <a:t>Understand &amp; Fix Basics</a:t>
+              <a:t>Assess &amp; Stabilise</a:t>
             </a:r>
           </a:p>
         </p:txBody>
@@ -7632,7 +7632,7 @@
                 </a:solidFill>
                 <a:latin typeface="Calibri"/>
               </a:rPr>
-              <a:t>Check open jobs, time at each step, source of hires &amp; who is leaving</a:t>
+              <a:t>Review open roles, time taken at each stage, sources of hire, and attrition by store</a:t>
             </a:r>
           </a:p>
           <a:p>
@@ -7660,7 +7660,7 @@
                 </a:solidFill>
                 <a:latin typeface="Calibri"/>
               </a:rPr>
-              <a:t>Make everyone use one hiring software (ATS)</a:t>
+              <a:t>Move all hiring onto a single applicant tracking system (ATS)</a:t>
             </a:r>
           </a:p>
           <a:p>
@@ -7688,7 +7688,7 @@
                 </a:solidFill>
                 <a:latin typeface="Calibri"/>
               </a:rPr>
-              <a:t>Daily focus team for the 100 new-store jobs</a:t>
+              <a:t>Dedicated team for the 100 new-store roles</a:t>
             </a:r>
           </a:p>
           <a:p>
@@ -7716,7 +7716,7 @@
                 </a:solidFill>
                 <a:latin typeface="Calibri"/>
               </a:rPr>
-              <a:t>Restart referral scheme with instant reward</a:t>
+              <a:t>Relaunch the employee referral programme with prompt payouts</a:t>
             </a:r>
           </a:p>
         </p:txBody>
@@ -7951,7 +7951,7 @@
                 </a:solidFill>
                 <a:latin typeface="Calibri"/>
               </a:rPr>
-              <a:t>Standard interview questions + culture-fit scorecards</a:t>
+              <a:t>Standardised interview kits + culture-fit scorecards</a:t>
             </a:r>
           </a:p>
           <a:p>
@@ -7979,7 +7979,7 @@
                 </a:solidFill>
                 <a:latin typeface="Calibri"/>
               </a:rPr>
-              <a:t>Keep ready, pre-checked candidate lists</a:t>
+              <a:t>Maintain pre-screened talent pipelines for high-volume roles</a:t>
             </a:r>
           </a:p>
           <a:p>
@@ -8007,7 +8007,7 @@
                 </a:solidFill>
                 <a:latin typeface="Calibri"/>
               </a:rPr>
-              <a:t>New-joinee plan: ready Day 1 + 30/60/90 check-ins</a:t>
+              <a:t>Redesign onboarding: ready from Day 1, with 30/60/90-day check-ins</a:t>
             </a:r>
           </a:p>
           <a:p>
@@ -8035,7 +8035,7 @@
                 </a:solidFill>
                 <a:latin typeface="Calibri"/>
               </a:rPr>
-              <a:t>Start AI screening + chatbot; cut agency contracts</a:t>
+              <a:t>Introduce AI screening + chatbot; reduce agency dependence</a:t>
             </a:r>
           </a:p>
         </p:txBody>
@@ -8219,7 +8219,7 @@
                 </a:solidFill>
                 <a:latin typeface="Calibri"/>
               </a:rPr>
-              <a:t>Show Results</a:t>
+              <a:t>Demonstrate Results</a:t>
             </a:r>
           </a:p>
         </p:txBody>
@@ -8270,7 +8270,7 @@
                 </a:solidFill>
                 <a:latin typeface="Calibri"/>
               </a:rPr>
-              <a:t>Early wins: hiring time ~40 days; fewer drop-outs</a:t>
+              <a:t>Early wins: time-to-hire ~40 days; fewer offer declines</a:t>
             </a:r>
           </a:p>
           <a:p>
@@ -8298,7 +8298,7 @@
                 </a:solidFill>
                 <a:latin typeface="Calibri"/>
               </a:rPr>
-              <a:t>Start employer-branding posts</a:t>
+              <a:t>Launch employer-branding content</a:t>
             </a:r>
           </a:p>
           <a:p>
@@ -8326,7 +8326,7 @@
                 </a:solidFill>
                 <a:latin typeface="Calibri"/>
               </a:rPr>
-              <a:t>Launch a live hiring dashboard for leadership</a:t>
+              <a:t>Go live with a real-time hiring dashboard for leadership</a:t>
             </a:r>
           </a:p>
           <a:p>
@@ -8354,7 +8354,7 @@
                 </a:solidFill>
                 <a:latin typeface="Calibri"/>
               </a:rPr>
-              <a:t>Present the full 12-month plan to leadership</a:t>
+              <a:t>Present the full 12-month roadmap to leadership</a:t>
             </a:r>
           </a:p>
         </p:txBody>
@@ -8826,7 +8826,7 @@
                 </a:solidFill>
                 <a:latin typeface="Calibri"/>
               </a:rPr>
-              <a:t>The 12-month plan in four quarters</a:t>
+              <a:t>The 12-month roadmap, in four quarters</a:t>
             </a:r>
           </a:p>
         </p:txBody>
@@ -8871,7 +8871,7 @@
                 </a:solidFill>
                 <a:latin typeface="Calibri"/>
               </a:rPr>
-              <a:t>Each quarter builds on the last. We finish one quarter's base work (the gate) before starting the next.</a:t>
+              <a:t>Each quarter builds on the previous one. We complete a quarter's foundation (its gate) before moving to the next.</a:t>
             </a:r>
           </a:p>
         </p:txBody>
@@ -9106,7 +9106,7 @@
                 </a:solidFill>
                 <a:latin typeface="Calibri"/>
               </a:rPr>
-              <a:t>Hiring software fully used</a:t>
+              <a:t>ATS fully adopted</a:t>
             </a:r>
           </a:p>
           <a:p>
@@ -9134,7 +9134,7 @@
                 </a:solidFill>
                 <a:latin typeface="Calibri"/>
               </a:rPr>
-              <a:t>Standard interviews</a:t>
+              <a:t>Standardised interviews</a:t>
             </a:r>
           </a:p>
           <a:p>
@@ -9162,7 +9162,7 @@
                 </a:solidFill>
                 <a:latin typeface="Calibri"/>
               </a:rPr>
-              <a:t>Referral scheme</a:t>
+              <a:t>Referral programme</a:t>
             </a:r>
           </a:p>
           <a:p>
@@ -9190,7 +9190,7 @@
                 </a:solidFill>
                 <a:latin typeface="Calibri"/>
               </a:rPr>
-              <a:t>New-joinee plan v2</a:t>
+              <a:t>Onboarding v2</a:t>
             </a:r>
           </a:p>
         </p:txBody>
@@ -9281,7 +9281,7 @@
                 </a:solidFill>
                 <a:latin typeface="Calibri"/>
               </a:rPr>
-              <a:t>Gate: ATS used by &gt;90%</a:t>
+              <a:t>Gate: ATS adoption &gt;90%</a:t>
             </a:r>
           </a:p>
         </p:txBody>
@@ -9544,7 +9544,7 @@
                 </a:solidFill>
                 <a:latin typeface="Calibri"/>
               </a:rPr>
-              <a:t>Ready lists, top 5 jobs</a:t>
+              <a:t>Pipelines for top 5 roles</a:t>
             </a:r>
           </a:p>
           <a:p>
@@ -9572,7 +9572,7 @@
                 </a:solidFill>
                 <a:latin typeface="Calibri"/>
               </a:rPr>
-              <a:t>Time limits per step</a:t>
+              <a:t>Stage-wise timelines</a:t>
             </a:r>
           </a:p>
         </p:txBody>
@@ -9663,7 +9663,7 @@
                 </a:solidFill>
                 <a:latin typeface="Calibri"/>
               </a:rPr>
-              <a:t>Gate: hiring time ≤35 days</a:t>
+              <a:t>Gate: time-to-hire ≤35 days</a:t>
             </a:r>
           </a:p>
         </p:txBody>
@@ -9926,7 +9926,7 @@
                 </a:solidFill>
                 <a:latin typeface="Calibri"/>
               </a:rPr>
-              <a:t>Leadership hiring guide</a:t>
+              <a:t>Leadership-hiring playbook</a:t>
             </a:r>
           </a:p>
           <a:p>
@@ -10045,7 +10045,7 @@
                 </a:solidFill>
                 <a:latin typeface="Calibri"/>
               </a:rPr>
-              <a:t>Gate: people leaving &lt;35%</a:t>
+              <a:t>Gate: attrition &lt;35%</a:t>
             </a:r>
           </a:p>
         </p:txBody>
@@ -10871,7 +10871,7 @@
                 </a:solidFill>
                 <a:latin typeface="Calibri"/>
               </a:rPr>
-              <a:t>A team that can hire 1,000+ people a year</a:t>
+              <a:t>A team built to hire 1,000+ people a year</a:t>
             </a:r>
           </a:p>
         </p:txBody>
@@ -10916,7 +10916,7 @@
                 </a:solidFill>
                 <a:latin typeface="Calibri"/>
               </a:rPr>
-              <a:t>A central expert team for tools, data &amp; standards, plus recruiters placed inside each business so they work closely and move fast. ~13–15 people in total.</a:t>
+              <a:t>A central team owning tools, data and standards, supported by recruiters embedded within each business for speed and closeness. ~13–15 people in total.</a:t>
             </a:r>
           </a:p>
         </p:txBody>
@@ -11233,7 +11233,7 @@
                 </a:solidFill>
                 <a:latin typeface="Calibri"/>
               </a:rPr>
-              <a:t>Store &amp; service staff hiring</a:t>
+              <a:t>Store &amp; service hiring</a:t>
             </a:r>
           </a:p>
         </p:txBody>
@@ -11779,7 +11779,7 @@
                 </a:solidFill>
                 <a:latin typeface="Calibri"/>
               </a:rPr>
-              <a:t>Senior hiring, in-house</a:t>
+              <a:t>Senior hiring, handled in-house</a:t>
             </a:r>
           </a:p>
         </p:txBody>
@@ -12007,7 +12007,7 @@
                 </a:solidFill>
                 <a:latin typeface="Calibri"/>
               </a:rPr>
-              <a:t>TA Ops &amp; Data</a:t>
+              <a:t>TA Ops &amp; Analytics</a:t>
             </a:r>
           </a:p>
         </p:txBody>
@@ -12052,7 +12052,7 @@
                 </a:solidFill>
                 <a:latin typeface="Calibri"/>
               </a:rPr>
-              <a:t>Software · AI · dashboards</a:t>
+              <a:t>Systems · AI · dashboards</a:t>
             </a:r>
           </a:p>
         </p:txBody>
@@ -12325,7 +12325,7 @@
                 </a:solidFill>
                 <a:latin typeface="Calibri"/>
               </a:rPr>
-              <a:t>Always-ready sourcing</a:t>
+              <a:t>Ongoing talent sourcing</a:t>
             </a:r>
           </a:p>
         </p:txBody>
@@ -12553,7 +12553,7 @@
                 </a:solidFill>
                 <a:latin typeface="Calibri"/>
               </a:rPr>
-              <a:t>Team size: </a:t>
+              <a:t>Team sizing: </a:t>
             </a:r>
             <a:r>
               <a:rPr sz="1250" b="0" i="0">
@@ -12562,7 +12562,7 @@
                 </a:solidFill>
                 <a:latin typeface="Calibri"/>
               </a:rPr>
-              <a:t>one volume recruiter handles ~120–150 hires/year, a corporate recruiter ~40–60 → ~6–7 recruiters, 3–4 sourcers, 1 data person, 1 branding person + 4 leads. Recruiters move from filling forms to sourcing, using data &amp; working with managers.</a:t>
+              <a:t>a volume recruiter handles ~120–150 hires/year and a corporate recruiter ~40–60 → roughly 6–7 recruiters, 3–4 sourcers, 1 analytics lead, 1 branding lead and 4 team leads. Recruiters shift from processing applications to sourcing, using data and partnering with managers.</a:t>
             </a:r>
           </a:p>
         </p:txBody>
@@ -13034,7 +13034,7 @@
                 </a:solidFill>
                 <a:latin typeface="Calibri"/>
               </a:rPr>
-              <a:t>Reduce hiring time from 50+ to 30 days or less</a:t>
+              <a:t>Reducing time-to-hire from 50+ to 30 days</a:t>
             </a:r>
           </a:p>
         </p:txBody>
@@ -13079,7 +13079,7 @@
                 </a:solidFill>
                 <a:latin typeface="Calibri"/>
               </a:rPr>
-              <a:t>Hiring is slow because we start from zero for every job and wait too long for manager feedback. The fix: keep candidates ready and run the steps together with clear time limits.</a:t>
+              <a:t>Hiring is slow because we start from scratch for every role and wait too long for manager feedback. The fix: keep candidates ready and run the stages in parallel, with clear timelines.</a:t>
             </a:r>
           </a:p>
         </p:txBody>
@@ -13308,7 +13308,7 @@
                 </a:solidFill>
                 <a:latin typeface="Calibri"/>
               </a:rPr>
-              <a:t>With ready lists</a:t>
+              <a:t>With pipelines</a:t>
             </a:r>
           </a:p>
         </p:txBody>
@@ -13492,7 +13492,7 @@
                 </a:solidFill>
                 <a:latin typeface="Calibri"/>
               </a:rPr>
-              <a:t>Goal</a:t>
+              <a:t>Target</a:t>
             </a:r>
           </a:p>
         </p:txBody>
@@ -13676,7 +13676,7 @@
                 </a:solidFill>
                 <a:latin typeface="Calibri"/>
               </a:rPr>
-              <a:t>Store jobs</a:t>
+              <a:t>Store roles</a:t>
             </a:r>
           </a:p>
         </p:txBody>
@@ -13952,7 +13952,7 @@
                 </a:solidFill>
                 <a:latin typeface="Calibri"/>
               </a:rPr>
-              <a:t>Example: </a:t>
+              <a:t>For reference: </a:t>
             </a:r>
             <a:r>
               <a:rPr sz="1250" b="0" i="0">
@@ -13961,7 +13961,7 @@
                 </a:solidFill>
                 <a:latin typeface="Calibri"/>
               </a:rPr>
-              <a:t>Chipotle hires in 4 days while hiring 10,000/year — so our 30-day goal is easy.</a:t>
+              <a:t>Chipotle hires in ~4 days at ~10,000 hires/year — so a 30-day target is well within reach.</a:t>
             </a:r>
           </a:p>
         </p:txBody>
@@ -14054,7 +14054,7 @@
                 </a:solidFill>
                 <a:latin typeface="Calibri"/>
               </a:rPr>
-              <a:t>🎯  HOW WE MAKE HIRING FASTER</a:t>
+              <a:t>🎯  HOW WE ACCELERATE HIRING</a:t>
             </a:r>
           </a:p>
         </p:txBody>
@@ -14105,7 +14105,7 @@
                 </a:solidFill>
                 <a:latin typeface="Calibri"/>
               </a:rPr>
-              <a:t>Keep ready candidate lists — </a:t>
+              <a:t>Use pre-screened pipelines — </a:t>
             </a:r>
             <a:r>
               <a:rPr sz="1200">
@@ -14114,7 +14114,7 @@
                 </a:solidFill>
                 <a:latin typeface="Calibri"/>
               </a:rPr>
-              <a:t>fill high-volume jobs in days, not weeks.</a:t>
+              <a:t>high-volume roles fill in days, not weeks.</a:t>
             </a:r>
           </a:p>
           <a:p>
@@ -14142,7 +14142,7 @@
                 </a:solidFill>
                 <a:latin typeface="Calibri"/>
               </a:rPr>
-              <a:t>Run steps together — </a:t>
+              <a:t>Run stages in parallel — </a:t>
             </a:r>
             <a:r>
               <a:rPr sz="1200">
@@ -14151,7 +14151,7 @@
                 </a:solidFill>
                 <a:latin typeface="Calibri"/>
               </a:rPr>
-              <a:t>screening, interview &amp; booking at once; AI screens 24×7.</a:t>
+              <a:t>screening, interview &amp; scheduling together; AI screens 24×7.</a:t>
             </a:r>
           </a:p>
           <a:p>
@@ -14179,7 +14179,7 @@
                 </a:solidFill>
                 <a:latin typeface="Calibri"/>
               </a:rPr>
-              <a:t>Fixed time limits — </a:t>
+              <a:t>Set stage timelines — </a:t>
             </a:r>
             <a:r>
               <a:rPr sz="1200">
@@ -14216,7 +14216,7 @@
                 </a:solidFill>
                 <a:latin typeface="Calibri"/>
               </a:rPr>
-              <a:t>Instant booking </a:t>
+              <a:t>Instant scheduling </a:t>
             </a:r>
             <a:r>
               <a:rPr sz="1200">
@@ -14225,7 +14225,7 @@
                 </a:solidFill>
                 <a:latin typeface="Calibri"/>
               </a:rPr>
-              <a:t>by chatbot for store jobs; ready panel for leadership.</a:t>
+              <a:t>via chatbot for store roles; ready panel for leadership.</a:t>
             </a:r>
           </a:p>
           <a:p>
@@ -14253,7 +14253,7 @@
                 </a:solidFill>
                 <a:latin typeface="Calibri"/>
               </a:rPr>
-              <a:t>Cut offer drop-outs 28% → under 12% </a:t>
+              <a:t>Reduce offer declines 28% → under 12% </a:t>
             </a:r>
             <a:r>
               <a:rPr sz="1200">
@@ -14262,7 +14262,7 @@
                 </a:solidFill>
                 <a:latin typeface="Calibri"/>
               </a:rPr>
-              <a:t>with a faster process &amp; clear salary.</a:t>
+              <a:t>with a quicker process &amp; clear compensation.</a:t>
             </a:r>
           </a:p>
         </p:txBody>
@@ -14547,7 +14547,7 @@
                 </a:solidFill>
                 <a:latin typeface="Calibri"/>
               </a:rPr>
-              <a:t>STOP PEOPLE LEAVING</a:t>
+              <a:t>REDUCING ATTRITION</a:t>
             </a:r>
           </a:p>
         </p:txBody>
@@ -14734,7 +14734,7 @@
                 </a:solidFill>
                 <a:latin typeface="Calibri"/>
               </a:rPr>
-              <a:t>Reduce people leaving: 45% to below 25%</a:t>
+              <a:t>Reducing attrition from 45% to below 25%</a:t>
             </a:r>
           </a:p>
         </p:txBody>
@@ -14779,7 +14779,7 @@
                 </a:solidFill>
                 <a:latin typeface="Calibri"/>
               </a:rPr>
-              <a:t>Most people leave in the first 3 months — about 20% within 45 days, and ~70% of all leavers within 90 days. So we must fix hiring, joining and early support. Keeping people starts from the day we hire.</a:t>
+              <a:t>Most exits happen in the first three months — about 20% within 45 days, and around 70% of all exits within 90 days. So we must strengthen hiring, onboarding and early support. Retention begins on the day of hire.</a:t>
             </a:r>
           </a:p>
         </p:txBody>
@@ -15490,7 +15490,7 @@
                 </a:solidFill>
                 <a:latin typeface="Calibri"/>
               </a:rPr>
-              <a:t>leave within 45 days</a:t>
+              <a:t>exit within 45 days</a:t>
             </a:r>
           </a:p>
         </p:txBody>
@@ -15649,7 +15649,7 @@
                 </a:solidFill>
                 <a:latin typeface="Calibri"/>
               </a:rPr>
-              <a:t>of leavers go by 90 days</a:t>
+              <a:t>of exits occur by 90 days</a:t>
             </a:r>
           </a:p>
         </p:txBody>
@@ -15808,7 +15808,7 @@
                 </a:solidFill>
                 <a:latin typeface="Calibri"/>
               </a:rPr>
-              <a:t>stay 3+ yrs if joined well</a:t>
+              <a:t>stay 3+ yrs with strong onboarding</a:t>
             </a:r>
           </a:p>
         </p:txBody>
@@ -15901,7 +15901,7 @@
                 </a:solidFill>
                 <a:latin typeface="Calibri"/>
               </a:rPr>
-              <a:t>🎯  OUR THREE-STEP PLAN</a:t>
+              <a:t>🎯  OUR THREE-PART APPROACH</a:t>
             </a:r>
           </a:p>
         </p:txBody>
@@ -15961,7 +15961,7 @@
                 </a:solidFill>
                 <a:latin typeface="Calibri"/>
               </a:rPr>
-              <a:t>check culture fit, show honest job preview, 40%+ referrals.</a:t>
+              <a:t>assess culture fit, give an honest role preview, raise referrals to 40%+.</a:t>
             </a:r>
           </a:p>
           <a:p>
@@ -15989,7 +15989,7 @@
                 </a:solidFill>
                 <a:latin typeface="Calibri"/>
               </a:rPr>
-              <a:t>B · Settle them well — </a:t>
+              <a:t>B · Onboard well — </a:t>
             </a:r>
             <a:r>
               <a:rPr sz="1200">
@@ -15998,7 +15998,7 @@
                 </a:solidFill>
                 <a:latin typeface="Calibri"/>
               </a:rPr>
-              <a:t>ready Day 1, give a buddy, check in at 30/60/90 days.</a:t>
+              <a:t>ready Day 1, assign a buddy, review at 30/60/90 days.</a:t>
             </a:r>
           </a:p>
           <a:p>
@@ -16026,7 +16026,7 @@
                 </a:solidFill>
                 <a:latin typeface="Calibri"/>
               </a:rPr>
-              <a:t>C · Keep them — </a:t>
+              <a:t>C · Retain — </a:t>
             </a:r>
             <a:r>
               <a:rPr sz="1200">
@@ -16035,7 +16035,7 @@
                 </a:solidFill>
                 <a:latin typeface="Calibri"/>
               </a:rPr>
-              <a:t>clear growth path + early alerts when someone may leave.</a:t>
+              <a:t>clear growth path + early warning signals when someone may leave.</a:t>
             </a:r>
           </a:p>
           <a:p>
@@ -16063,7 +16063,7 @@
                 </a:solidFill>
                 <a:latin typeface="Calibri"/>
               </a:rPr>
-              <a:t>Start with </a:t>
+              <a:t>Prioritise </a:t>
             </a:r>
             <a:r>
               <a:rPr sz="1200">
@@ -16072,7 +16072,7 @@
                 </a:solidFill>
                 <a:latin typeface="Calibri"/>
               </a:rPr>
-              <a:t>store staff (55%+) and the 11-month problem first.</a:t>
+              <a:t>store staff (55%+) and the 11-month tenure issue first.</a:t>
             </a:r>
           </a:p>
         </p:txBody>
@@ -16544,7 +16544,7 @@
                 </a:solidFill>
                 <a:latin typeface="Calibri"/>
               </a:rPr>
-              <a:t>AI gives speed — and cuts the cost in half</a:t>
+              <a:t>AI drives speed — and reduces cost by half</a:t>
             </a:r>
           </a:p>
         </p:txBody>
@@ -16589,7 +16589,7 @@
                 </a:solidFill>
                 <a:latin typeface="Calibri"/>
               </a:rPr>
-              <a:t>AI handles the repeated work — searching, screening, scheduling and answering candidate questions. Cost mainly drops from more referrals, fewer agencies, and fewer re-hires.</a:t>
+              <a:t>AI handles the repetitive work — sourcing, screening, scheduling and candidate queries — that currently consumes recruiter time and agency fees. Cost falls mainly through more referrals, fewer agencies, and fewer re-hires.</a:t>
             </a:r>
           </a:p>
         </p:txBody>
@@ -16682,7 +16682,7 @@
                 </a:solidFill>
                 <a:latin typeface="Calibri"/>
               </a:rPr>
-              <a:t>🤖  HIRING TOOLS — STEP BY STEP</a:t>
+              <a:t>🤖  TECHNOLOGY STACK — PHASED</a:t>
             </a:r>
           </a:p>
         </p:txBody>
@@ -16733,7 +16733,7 @@
                 </a:solidFill>
                 <a:latin typeface="Calibri"/>
               </a:rPr>
-              <a:t>Step 1 — </a:t>
+              <a:t>Phase 1 — </a:t>
             </a:r>
             <a:r>
               <a:rPr sz="1200">
@@ -16742,7 +16742,7 @@
                 </a:solidFill>
                 <a:latin typeface="Calibri"/>
               </a:rPr>
-              <a:t>full hiring software (ATS) + live dashboards.</a:t>
+              <a:t>full ATS + live dashboards (the data foundation).</a:t>
             </a:r>
           </a:p>
           <a:p>
@@ -16770,7 +16770,7 @@
                 </a:solidFill>
                 <a:latin typeface="Calibri"/>
               </a:rPr>
-              <a:t>Step 2 — </a:t>
+              <a:t>Phase 2 — </a:t>
             </a:r>
             <a:r>
               <a:rPr sz="1200">
@@ -16779,7 +16779,7 @@
                 </a:solidFill>
                 <a:latin typeface="Calibri"/>
               </a:rPr>
-              <a:t>AI screening + a WhatsApp/chat assistant for big-volume jobs.</a:t>
+              <a:t>AI screening + a WhatsApp/chat assistant for high-volume roles.</a:t>
             </a:r>
           </a:p>
           <a:p>
@@ -16807,7 +16807,7 @@
                 </a:solidFill>
                 <a:latin typeface="Calibri"/>
               </a:rPr>
-              <a:t>Step 3 — </a:t>
+              <a:t>Phase 3 — </a:t>
             </a:r>
             <a:r>
               <a:rPr sz="1200">
@@ -16816,7 +16816,7 @@
                 </a:solidFill>
                 <a:latin typeface="Calibri"/>
               </a:rPr>
-              <a:t>AI candidate search + early alerts on who may leave.</a:t>
+              <a:t>AI sourcing + early attrition warning signals.</a:t>
             </a:r>
           </a:p>
           <a:p>
@@ -16844,7 +16844,7 @@
                 </a:solidFill>
                 <a:latin typeface="Calibri"/>
               </a:rPr>
-              <a:t>Plus job ads on social media.</a:t>
+              <a:t>Plus job advertising across social media.</a:t>
             </a:r>
           </a:p>
         </p:txBody>
@@ -16997,7 +16997,7 @@
                 </a:solidFill>
                 <a:latin typeface="Calibri"/>
               </a:rPr>
-              <a:t>cheapest channel, and people stay longer.</a:t>
+              <a:t>the lowest-cost channel, with better retention.</a:t>
             </a:r>
           </a:p>
           <a:p>
@@ -17034,7 +17034,7 @@
                 </a:solidFill>
                 <a:latin typeface="Calibri"/>
               </a:rPr>
-              <a:t>do sourcing &amp; leadership hiring in-house.</a:t>
+              <a:t>bring sourcing &amp; leadership hiring in-house.</a:t>
             </a:r>
           </a:p>
           <a:p>
@@ -17099,7 +17099,7 @@
                 </a:solidFill>
                 <a:latin typeface="Calibri"/>
               </a:rPr>
-              <a:t>Less leaving — </a:t>
+              <a:t>Lower attrition — </a:t>
             </a:r>
             <a:r>
               <a:rPr sz="1200">
@@ -17108,7 +17108,7 @@
                 </a:solidFill>
                 <a:latin typeface="Calibri"/>
               </a:rPr>
-              <a:t>each avoided replacement saves a full hire + training.</a:t>
+              <a:t>each avoided replacement saves a full hiring cost + training time.</a:t>
             </a:r>
           </a:p>
         </p:txBody>
@@ -17245,7 +17245,7 @@
                 </a:solidFill>
                 <a:latin typeface="Calibri"/>
               </a:rPr>
-              <a:t>The good cycle: </a:t>
+              <a:t>A positive cycle: </a:t>
             </a:r>
             <a:r>
               <a:rPr sz="1250" b="0" i="0">
@@ -17254,7 +17254,7 @@
                 </a:solidFill>
                 <a:latin typeface="Calibri"/>
               </a:rPr>
-              <a:t>referrals stay longer → fewer people leave → fewer re-hires → recruiters focus on growth, not replacement → agency money moves to cheaper, better channels.</a:t>
+              <a:t>referrals stay longer → attrition falls → fewer re-hires → recruiters focus on growth rather than replacement → agency budget shifts to lower-cost, higher-quality channels.</a:t>
             </a:r>
           </a:p>
         </p:txBody>
@@ -17539,7 +17539,7 @@
                 </a:solidFill>
                 <a:latin typeface="Calibri"/>
               </a:rPr>
-              <a:t>MEASURE &amp; PROTECT</a:t>
+              <a:t>METRICS &amp; GOVERNANCE</a:t>
             </a:r>
           </a:p>
         </p:txBody>
@@ -17726,7 +17726,7 @@
                 </a:solidFill>
                 <a:latin typeface="Calibri"/>
               </a:rPr>
-              <a:t>How we measure progress — and reduce risk</a:t>
+              <a:t>How we measure progress — and manage risk</a:t>
             </a:r>
           </a:p>
         </p:txBody>
@@ -17815,7 +17815,7 @@
                 </a:solidFill>
                 <a:latin typeface="Calibri"/>
               </a:rPr>
-              <a:t>WHAT WE TRACK</a:t>
+              <a:t>METRIC</a:t>
             </a:r>
           </a:p>
         </p:txBody>
@@ -17905,7 +17905,7 @@
                 </a:solidFill>
                 <a:latin typeface="Calibri"/>
               </a:rPr>
-              <a:t>GOAL</a:t>
+              <a:t>TARGET</a:t>
             </a:r>
           </a:p>
         </p:txBody>
@@ -18038,7 +18038,7 @@
                 </a:solidFill>
                 <a:latin typeface="Calibri"/>
               </a:rPr>
-              <a:t>Hiring time</a:t>
+              <a:t>Time-to-hire</a:t>
             </a:r>
           </a:p>
         </p:txBody>
@@ -19110,7 +19110,7 @@
                 </a:solidFill>
                 <a:latin typeface="Calibri"/>
               </a:rPr>
-              <a:t>Offer drop-outs</a:t>
+              <a:t>Offer declines</a:t>
             </a:r>
           </a:p>
         </p:txBody>
@@ -19378,7 +19378,7 @@
                 </a:solidFill>
                 <a:latin typeface="Calibri"/>
               </a:rPr>
-              <a:t>People leaving</a:t>
+              <a:t>Attrition</a:t>
             </a:r>
           </a:p>
         </p:txBody>
@@ -19646,7 +19646,7 @@
                 </a:solidFill>
                 <a:latin typeface="Calibri"/>
               </a:rPr>
-              <a:t>Stay past 90 days</a:t>
+              <a:t>90-day retention</a:t>
             </a:r>
           </a:p>
         </p:txBody>
@@ -19918,7 +19918,7 @@
                 </a:solidFill>
                 <a:latin typeface="Calibri"/>
               </a:rPr>
-              <a:t>Best early signal: </a:t>
+              <a:t>Key leading indicator: </a:t>
             </a:r>
             <a:r>
               <a:rPr sz="1250" b="0" i="0">
@@ -19927,7 +19927,7 @@
                 </a:solidFill>
                 <a:latin typeface="Calibri"/>
               </a:rPr>
-              <a:t>how many new joinees stay past 90 days — it warns us before yearly attrition rises.</a:t>
+              <a:t>90-day retention — it signals attrition months before the annual figure moves.</a:t>
             </a:r>
           </a:p>
         </p:txBody>
@@ -20020,7 +20020,7 @@
                 </a:solidFill>
                 <a:latin typeface="Calibri"/>
               </a:rPr>
-              <a:t>⚠  RISK → WHAT WE DO</a:t>
+              <a:t>⚠  RISK → RESPONSE</a:t>
             </a:r>
           </a:p>
         </p:txBody>
@@ -20071,7 +20071,7 @@
                 </a:solidFill>
                 <a:latin typeface="Calibri"/>
               </a:rPr>
-              <a:t>Competitors hiring fast → </a:t>
+              <a:t>Aggressive competitor hiring → </a:t>
             </a:r>
             <a:r>
               <a:rPr sz="1200">
@@ -20080,7 +20080,7 @@
                 </a:solidFill>
                 <a:latin typeface="Calibri"/>
               </a:rPr>
-              <a:t>strong brand + quicker offers + referrals.</a:t>
+              <a:t>stronger brand + quicker offers + referrals.</a:t>
             </a:r>
           </a:p>
           <a:p>
@@ -20117,7 +20117,7 @@
                 </a:solidFill>
                 <a:latin typeface="Calibri"/>
               </a:rPr>
-              <a:t>ready candidate lists + proper assessment.</a:t>
+              <a:t>talent pipelines + structured assessment.</a:t>
             </a:r>
           </a:p>
           <a:p>
@@ -20154,7 +20154,7 @@
                 </a:solidFill>
                 <a:latin typeface="Calibri"/>
               </a:rPr>
-              <a:t>focus first on joining &amp; the first 90 days.</a:t>
+              <a:t>prioritise onboarding and the first 90 days.</a:t>
             </a:r>
           </a:p>
           <a:p>
@@ -20182,7 +20182,7 @@
                 </a:solidFill>
                 <a:latin typeface="Calibri"/>
               </a:rPr>
-              <a:t>Slow software adoption → </a:t>
+              <a:t>Slow system adoption → </a:t>
             </a:r>
             <a:r>
               <a:rPr sz="1200">
@@ -20191,7 +20191,7 @@
                 </a:solidFill>
                 <a:latin typeface="Calibri"/>
               </a:rPr>
-              <a:t>make ATS compulsory; link to manager reviews.</a:t>
+              <a:t>make ATS mandatory; link to manager reviews.</a:t>
             </a:r>
           </a:p>
           <a:p>
@@ -20228,7 +20228,7 @@
                 </a:solidFill>
                 <a:latin typeface="Calibri"/>
               </a:rPr>
-              <a:t>100-hire buffer + ready candidate lists.</a:t>
+              <a:t>100-hire buffer + ready pipelines.</a:t>
             </a:r>
           </a:p>
         </p:txBody>
@@ -20282,7 +20282,7 @@
                 </a:solidFill>
                 <a:latin typeface="Calibri"/>
               </a:rPr>
-              <a:t>weekly team review (operations) · monthly review with CEO/CHRO (strategy).</a:t>
+              <a:t>a weekly operational review · a monthly strategic review with the CEO/CHRO.</a:t>
             </a:r>
           </a:p>
         </p:txBody>

</xml_diff>